<commit_message>
Small correction to presentation
</commit_message>
<xml_diff>
--- a/talk/the-threat-model-was-never-the-point.pptx
+++ b/talk/the-threat-model-was-never-the-point.pptx
@@ -311,24 +311,7 @@
           <a:bodyPr/>
           <a:lstStyle/>
           <a:p>
-            <a:r>
-              <a:t>2:00.</a:t>
-            </a:r>
-          </a:p>
-          <a:p>
-            <a:r>
-              <a:t>BEATS: (1) four ingredients, three of them varied. (2) The room is held constant, same seven people every run. (3) The distinction that carries the whole talk: missing versus inadequate.</a:t>
-            </a:r>
-          </a:p>
-          <a:p>
-            <a:r>
-              <a:t>SAY: context is not just the repo. On a greenfield project there may be no application code yet, and you still have Terraform, Helm and policy config that define your controls. That is the ingredient.</a:t>
-            </a:r>
-          </a:p>
-          <a:p>
-            <a:r>
-              <a:t>LAND: "A missing ingredient leaves a gap you can see. An inadequate one fills the gap with something the right shape."</a:t>
-            </a:r>
+            <a:endParaRPr dirty="0"/>
           </a:p>
         </p:txBody>
       </p:sp>
@@ -396,24 +379,7 @@
           <a:bodyPr/>
           <a:lstStyle/>
           <a:p>
-            <a:r>
-              <a:t>3:00. Paul called this the data slide. Let it breathe.</a:t>
-            </a:r>
-          </a:p>
-          <a:p>
-            <a:r>
-              <a:t>BEATS: (1) Top three rows are the before and after. (2) Net movement: four packs improve, one collapses. (3) Session length against findings reached, and the run 4 versus run 5 comparison in the notes. (4) The bottom row.</a:t>
-            </a:r>
-          </a:p>
-          <a:p>
-            <a:r>
-              <a:t>THE FACTS ROW READS BACKWARDS IF YOU LET IT: lowest is best. Say so before anyone squints.</a:t>
-            </a:r>
-          </a:p>
-          <a:p>
-            <a:r>
-              <a:t>DO NOT: quote person-minutes per finding. The five cells count findings reached on different bases and the ranking inverts when you normalise it.</a:t>
-            </a:r>
+            <a:endParaRPr dirty="0"/>
           </a:p>
         </p:txBody>
       </p:sp>
@@ -481,19 +447,7 @@
           <a:bodyPr/>
           <a:lstStyle/>
           <a:p>
-            <a:r>
-              <a:t>3:00. Paul's favourite slide, and he was right that the old ordering confused it.</a:t>
-            </a:r>
-          </a:p>
-          <a:p>
-            <a:r>
-              <a:t>BEATS: (1) Same threat, all five packs found it. (2) Walk down in column order. (3) Arrive at 244 last and say it: more words is not more quality.</a:t>
-            </a:r>
-          </a:p>
-          <a:p>
-            <a:r>
-              <a:t>LAND: "Seven hundred words are not better than two hundred and forty-four meaningful ones." Four of the five are usable. The one that is not had the repository, the chain and the prompt.</a:t>
-            </a:r>
+            <a:endParaRPr dirty="0"/>
           </a:p>
         </p:txBody>
       </p:sp>
@@ -561,24 +515,7 @@
           <a:bodyPr/>
           <a:lstStyle/>
           <a:p>
-            <a:r>
-              <a:t>2:30.</a:t>
-            </a:r>
-          </a:p>
-          <a:p>
-            <a:r>
-              <a:t>BEATS: (1) Top row, read across. Three cells had the repository; one tells you where to look. (2) The weak model's row of zeros. (3) The severity row, where every pack fails including the best one.</a:t>
-            </a:r>
-          </a:p>
-          <a:p>
-            <a:r>
-              <a:t>SAY, if the cheap-model advocate is in the room: someone will say the agent will just find it. It will, and it will burn context re-deriving a location the model could have written down once. I did not measure that, so do not quote a number.</a:t>
-            </a:r>
-          </a:p>
-          <a:p>
-            <a:r>
-              <a:t>DO NOT: raise reading grades unprompted. If asked: we measured it, the target was twelfth grade, and four of the five packs missed it.</a:t>
-            </a:r>
+            <a:endParaRPr dirty="0"/>
           </a:p>
         </p:txBody>
       </p:sp>
@@ -646,24 +583,7 @@
           <a:bodyPr/>
           <a:lstStyle/>
           <a:p>
-            <a:r>
-              <a:t>2:30. This is the takeaway slide. Slow down.</a:t>
-            </a:r>
-          </a:p>
-          <a:p>
-            <a:r>
-              <a:t>BEATS: (1) Four checks on a finding, one on the pack. (2) Every one usable by a product owner or a tester. (3) The fifth one is new and it is the one that matters most here.</a:t>
-            </a:r>
-          </a:p>
-          <a:p>
-            <a:r>
-              <a:t>SAY: I got caught by this myself, repeatedly. Several numbers in earlier versions of this deck came from a pack's description of itself rather than from counting, and every one of them was wrong. Never quote a pack's claim about itself. Count it.</a:t>
-            </a:r>
-          </a:p>
-          <a:p>
-            <a:r>
-              <a:t>LAND: "Give these to your champions."</a:t>
-            </a:r>
+            <a:endParaRPr dirty="0"/>
           </a:p>
         </p:txBody>
       </p:sp>
@@ -731,24 +651,7 @@
           <a:bodyPr/>
           <a:lstStyle/>
           <a:p>
-            <a:r>
-              <a:t>2:30.</a:t>
-            </a:r>
-          </a:p>
-          <a:p>
-            <a:r>
-              <a:t>BEATS: (1) Added, closed, re-rated, and got things wrong. All four, or nobody believes the slide. (2) The minus eleven was not the room. (3) The refusal quote.</a:t>
-            </a:r>
-          </a:p>
-          <a:p>
-            <a:r>
-              <a:t>SAY: the model knew Slack Connect channels were possible. Tom knew there were three, and which two enterprise accounts were behind them. That difference is what makes a product owner act. And two people believed the egress proxy covered the markdown vector; the model reasoned about where a browser fetch starts and was right.</a:t>
-            </a:r>
-          </a:p>
-          <a:p>
-            <a:r>
-              <a:t>LAND: a session where humans only correct the model is a review. One where it corrects them back is what builds shared understanding.</a:t>
-            </a:r>
+            <a:endParaRPr dirty="0"/>
           </a:p>
         </p:txBody>
       </p:sp>
@@ -816,29 +719,7 @@
           <a:bodyPr/>
           <a:lstStyle/>
           <a:p>
-            <a:r>
-              <a:t>3:00. Do not add a thank-you slide. The line is the close.</a:t>
-            </a:r>
-          </a:p>
-          <a:p>
-            <a:r>
-              <a:t>BEATS: (1) The threat model was never the product. (2) The bonus: you did the security work and the engineering context came free. Nine documents, not one. (3) The learning spreads by osmosis, and that is the return nobody puts on a business case. (4) The last line, then stop.</a:t>
-            </a:r>
-          </a:p>
-          <a:p>
-            <a:r>
-              <a:t>LAND, verbatim: "A model can produce a document. Only a room can produce collective understanding. That is the part that cannot be automated away."</a:t>
-            </a:r>
-          </a:p>
-          <a:p>
-            <a:r>
-              <a:t>THEN: the skills are being open sourced. Say it is in progress.</a:t>
-            </a:r>
-          </a:p>
-          <a:p>
-            <a:r>
-              <a:t>Q: how many reps? A: one. Everything here is n=1 and one of the five stopped on a rate limit. Say it before anyone asks.</a:t>
-            </a:r>
+            <a:endParaRPr dirty="0"/>
           </a:p>
         </p:txBody>
       </p:sp>
@@ -906,29 +787,7 @@
           <a:bodyPr/>
           <a:lstStyle/>
           <a:p>
-            <a:r>
-              <a:t>3:00. The densest speaking slide in the deck. This is the whole methodology.</a:t>
-            </a:r>
-          </a:p>
-          <a:p>
-            <a:r>
-              <a:t>BEATS, one per row, top to bottom: (1) weak model, everything supplied except reasoning, 13 findings. (2) Weak skill, a 27-line STRIDE prompt, 35. (3) Thin, almost no context at all, and it beats both of them at 74. (4) No repo, everything but the code, 71. (5) Everything, 75.</a:t>
-            </a:r>
-          </a:p>
-          <a:p>
-            <a:r>
-              <a:t>THE MOMENT: thin is third, not first, and here is why. The chain does not only read context, it builds the thing it is going to analyse. Given an epic and one diagram it still writes out the requirements and the architecture, flags every part it had to assume, and threat-models against that. Whatever you call the result, it gave the analysis something to bite on, and the flagged assumptions are what the room corrects first. Caveat if pressed: three variables differ between these two cells and n is one.</a:t>
-            </a:r>
-          </a:p>
-          <a:p>
-            <a:r>
-              <a:t>COST, once, then never again: these are token costs for the automation. The room is not priced here at all, and neither is building a pack by hand, because I measured neither. Do not offer a number for either. The honest line is that the human time dwarfs the token cost and nobody in the room will argue with that. Move on.</a:t>
-            </a:r>
-          </a:p>
-          <a:p>
-            <a:r>
-              <a:t>DO NOT: get drawn into cost-per-finding. It is in the reports if anyone wants it.</a:t>
-            </a:r>
+            <a:endParaRPr dirty="0"/>
           </a:p>
         </p:txBody>
       </p:sp>
@@ -996,34 +855,7 @@
           <a:bodyPr/>
           <a:lstStyle/>
           <a:p>
-            <a:r>
-              <a:t>3:00. Paul needed this explained, so explain it.</a:t>
-            </a:r>
-          </a:p>
-          <a:p>
-            <a:r>
-              <a:t>BEATS: (1) Three bands, left to right, hardest on the right. (2) Look at the weak skill row: eight of eight, five of five, and the right-hand column says nothing closeable. (3) Only one row is green across all three.</a:t>
-            </a:r>
-          </a:p>
-          <a:p>
-            <a:r>
-              <a:t>SAY: people have rolled their own, and that is fine. What we found is that with a less mature skill you spend your time decoding the output instead of getting on with it. What you want is to go straight into Jira tickets, or straight into the session.</a:t>
-            </a:r>
-          </a:p>
-          <a:p>
-            <a:r>
-              <a:t>Q: why is thin so low on drift? A: all eight need the repository and it had none. The two it scored came from the room, not from the pack.</a:t>
-            </a:r>
-          </a:p>
-          <a:p>
-            <a:r>
-              <a:t>Q: is it the prompt or the reference material? A: both, and neither on its own. In the revision pass run 2 opened all five of the missing sections and produced no new findings in any of them, only cross-references to what it already had. It had the headings and not the catalogues. Knowing to ask is not enough.</a:t>
-            </a:r>
-          </a:p>
-          <a:p>
-            <a:r>
-              <a:t>AND THE THIRD THING: the chain runs two skills before the threat model. One solicits the missing context and classifies requirements, the other defines the architecture. The threat model then runs against a constructed system rather than a prose description. The weak skill has nothing to enumerate against except the text it was handed.</a:t>
-            </a:r>
+            <a:endParaRPr dirty="0"/>
           </a:p>
         </p:txBody>
       </p:sp>
@@ -1091,24 +923,7 @@
           <a:bodyPr/>
           <a:lstStyle/>
           <a:p>
-            <a:r>
-              <a:t>1:30. Structural. Do not linger.</a:t>
-            </a:r>
-          </a:p>
-          <a:p>
-            <a:r>
-              <a:t>BEATS: (1) Phases 1 and 3 are the same model run twice. (2) The room sits between them, so every cell is a before and after. Eleven runs in the costed pipeline: five before, five after, one directed. Sixteen model runs actually executed, because generating each transcript is itself a model pass. (3) The caveat, said plainly.</a:t>
-            </a:r>
-          </a:p>
-          <a:p>
-            <a:r>
-              <a:t>THE CAVEAT: the transcript is generated. It is not invented noise, though. The room was given seven facts authored ahead of the runs and deliberately withheld from the context, and each fact is classified per cell as surfaced, instance-only or already-in-pack so the room cannot be credited with something the pack already held.</a:t>
-            </a:r>
-          </a:p>
-          <a:p>
-            <a:r>
-              <a:t>Q: isn't a simulated room circular? A: the facts are independently specified, and the classification is the control. What it does not prove is that a real room holds seven facts.</a:t>
-            </a:r>
+            <a:endParaRPr dirty="0"/>
           </a:p>
         </p:txBody>
       </p:sp>
@@ -1176,24 +991,7 @@
           <a:bodyPr/>
           <a:lstStyle/>
           <a:p>
-            <a:r>
-              <a:t>2:30.</a:t>
-            </a:r>
-          </a:p>
-          <a:p>
-            <a:r>
-              <a:t>BEATS: (1) Read the left column aloud, then the right. Nothing is paraphrased. (2) Then the third file: all documents are production-ready, no known gaps remain. (3) The band is the same failure in bookkeeping form.</a:t>
-            </a:r>
-          </a:p>
-          <a:p>
-            <a:r>
-              <a:t>LAND: "The only variable left is the model."</a:t>
-            </a:r>
-          </a:p>
-          <a:p>
-            <a:r>
-              <a:t>Q: would a reviewer catch this? A: twelve documents, every section headed, a status emoji on every row, four navigation guides asserting completeness. It fails no check a reader performs by scanning. That is the point of the talk.</a:t>
-            </a:r>
+            <a:endParaRPr dirty="0"/>
           </a:p>
         </p:txBody>
       </p:sp>
@@ -1261,24 +1059,7 @@
           <a:bodyPr/>
           <a:lstStyle/>
           <a:p>
-            <a:r>
-              <a:t>3:00. This is the measure a recall score cannot give you.</a:t>
-            </a:r>
-          </a:p>
-          <a:p>
-            <a:r>
-              <a:t>TWO DIFFERENT ZEROS, and the difference matters. Cloud, container, resilience and cross-cutting have no STRIDE letter at all, so those zeros are a taxonomy gap. Agentic is not: STRIDE would have taken prompt injection as tampering, or as elevation of privilege once the injected instruction makes the model act beyond its authority. It filed it under spoofing, which is identity. That zero is a classification error, and a finding in the wrong bucket is one nobody searching the right bucket will ever find.</a:t>
-            </a:r>
-          </a:p>
-          <a:p>
-            <a:r>
-              <a:t>BEATS: (1) The weak model's 13 spoofing findings are not spoofing findings. It labelled everything S-. (2) Read down the weak skill column: zero agentic, zero cloud, zero container, zero resilience, zero cross-cutting. On a system whose entire point is an AI assistant with five connectors and tool-calling. (3) More than half the reference pack, thirty-nine of seventy-five, is in categories it has no name for.</a:t>
-            </a:r>
-          </a:p>
-          <a:p>
-            <a:r>
-              <a:t>DO NOT: quote a recall or probe score here. The planted-drift list is a floor test and putting a total on a slide invites the objection it deserves.</a:t>
-            </a:r>
+            <a:endParaRPr dirty="0"/>
           </a:p>
         </p:txBody>
       </p:sp>
@@ -1346,34 +1127,7 @@
           <a:bodyPr/>
           <a:lstStyle/>
           <a:p>
-            <a:r>
-              <a:t>3:00. Paul needed this explained, so explain it.</a:t>
-            </a:r>
-          </a:p>
-          <a:p>
-            <a:r>
-              <a:t>BEATS: (1) Three bands, left to right, hardest on the right. (2) Look at the weak skill row: eight of eight, five of five, and the right-hand column says nothing closeable. (3) Only one row is green across all three.</a:t>
-            </a:r>
-          </a:p>
-          <a:p>
-            <a:r>
-              <a:t>SAY: people have rolled their own, and that is fine. What we found is that with a less mature skill you spend your time decoding the output instead of getting on with it. What you want is to go straight into Jira tickets, or straight into the session.</a:t>
-            </a:r>
-          </a:p>
-          <a:p>
-            <a:r>
-              <a:t>Q: why is thin so low on drift? A: all eight need the repository and it had none. The two it scored came from the room, not from the pack.</a:t>
-            </a:r>
-          </a:p>
-          <a:p>
-            <a:r>
-              <a:t>Q: is it the prompt or the reference material? A: both, and neither on its own. In the revision pass run 2 opened all five of the missing sections and produced no new findings in any of them, only cross-references to what it already had. It had the headings and not the catalogues. Knowing to ask is not enough.</a:t>
-            </a:r>
-          </a:p>
-          <a:p>
-            <a:r>
-              <a:t>AND THE THIRD THING: the chain runs two skills before the threat model. One solicits the missing context and classifies requirements, the other defines the architecture. The threat model then runs against a constructed system rather than a prose description. The weak skill has nothing to enumerate against except the text it was handed.</a:t>
-            </a:r>
+            <a:endParaRPr dirty="0"/>
           </a:p>
         </p:txBody>
       </p:sp>
@@ -1441,34 +1195,7 @@
           <a:bodyPr/>
           <a:lstStyle/>
           <a:p>
-            <a:r>
-              <a:t>3:00. Paul needed this explained, so explain it.</a:t>
-            </a:r>
-          </a:p>
-          <a:p>
-            <a:r>
-              <a:t>BEATS: (1) Three bands, left to right, hardest on the right. (2) Look at the weak skill row: eight of eight, five of five, and the right-hand column says nothing closeable. (3) Only one row is green across all three.</a:t>
-            </a:r>
-          </a:p>
-          <a:p>
-            <a:r>
-              <a:t>SAY: people have rolled their own, and that is fine. What we found is that with a less mature skill you spend your time decoding the output instead of getting on with it. What you want is to go straight into Jira tickets, or straight into the session.</a:t>
-            </a:r>
-          </a:p>
-          <a:p>
-            <a:r>
-              <a:t>Q: why is thin so low on drift? A: all eight need the repository and it had none. The two it scored came from the room, not from the pack.</a:t>
-            </a:r>
-          </a:p>
-          <a:p>
-            <a:r>
-              <a:t>Q: is it the prompt or the reference material? A: both, and neither on its own. In the revision pass run 2 opened all five of the missing sections and produced no new findings in any of them, only cross-references to what it already had. It had the headings and not the catalogues. Knowing to ask is not enough.</a:t>
-            </a:r>
-          </a:p>
-          <a:p>
-            <a:r>
-              <a:t>AND THE THIRD THING: the chain runs two skills before the threat model. One solicits the missing context and classifies requirements, the other defines the architecture. The threat model then runs against a constructed system rather than a prose description. The weak skill has nothing to enumerate against except the text it was handed.</a:t>
-            </a:r>
+            <a:endParaRPr dirty="0"/>
           </a:p>
         </p:txBody>
       </p:sp>
@@ -1536,34 +1263,7 @@
           <a:bodyPr/>
           <a:lstStyle/>
           <a:p>
-            <a:r>
-              <a:t>3:00. Paul needed this explained, so explain it.</a:t>
-            </a:r>
-          </a:p>
-          <a:p>
-            <a:r>
-              <a:t>BEATS: (1) Three bands, left to right, hardest on the right. (2) Look at the weak skill row: eight of eight, five of five, and the right-hand column says nothing closeable. (3) Only one row is green across all three.</a:t>
-            </a:r>
-          </a:p>
-          <a:p>
-            <a:r>
-              <a:t>SAY: people have rolled their own, and that is fine. What we found is that with a less mature skill you spend your time decoding the output instead of getting on with it. What you want is to go straight into Jira tickets, or straight into the session.</a:t>
-            </a:r>
-          </a:p>
-          <a:p>
-            <a:r>
-              <a:t>Q: why is thin so low on drift? A: all eight need the repository and it had none. The two it scored came from the room, not from the pack.</a:t>
-            </a:r>
-          </a:p>
-          <a:p>
-            <a:r>
-              <a:t>Q: is it the prompt or the reference material? A: both, and neither on its own. In the revision pass run 2 opened all five of the missing sections and produced no new findings in any of them, only cross-references to what it already had. It had the headings and not the catalogues. Knowing to ask is not enough.</a:t>
-            </a:r>
-          </a:p>
-          <a:p>
-            <a:r>
-              <a:t>AND THE THIRD THING: the chain runs two skills before the threat model. One solicits the missing context and classifies requirements, the other defines the architecture. The threat model then runs against a constructed system rather than a prose description. The weak skill has nothing to enumerate against except the text it was handed.</a:t>
-            </a:r>
+            <a:endParaRPr dirty="0"/>
           </a:p>
         </p:txBody>
       </p:sp>
@@ -7048,7 +6748,7 @@
                 </a:solidFill>
                 <a:latin typeface="Georgia"/>
               </a:rPr>
-              <a:t>Ordered as the columns, not by length. The best entry is the second shortest, and it is the only one that hands you a header you can paste.</a:t>
+              <a:t>Ordered as the columns, not by length. The best entry is the second shortest: three of the five hand you a header you can paste, and only this one is the finding and nothing else.</a:t>
             </a:r>
           </a:p>
         </p:txBody>

</xml_diff>